<commit_message>
v0.9.2 — deck + docs aligned with shipped v0.9.1
- PITCH-DECK: real ssjjul3 URLs on slide 1 + 12 (regenerated)
- README: live URL badges, Phase 0.5/0.9 status, current repo layout
- docs/MVP.md: Token Terminal, Engine tab, Workbench Terminal, dual tutorials, solana-connect
- docs/REPO-STRUCTURE.md: reframed as Phase 1 target
- docs/EXECUTION-CHECKLIST.md: Day 0 marked DONE
- docs/X-LAUNCH.md + VIDEO-SCRIPT.md: real URLs
</commit_message>
<xml_diff>
--- a/PITCH-DECK.pptx
+++ b/PITCH-DECK.pptx
@@ -4602,7 +4602,7 @@
                 </a:solidFill>
                 <a:latin typeface="Consolas"/>
               </a:rPr>
-              <a:t>github.com/chartrunner-xyz</a:t>
+              <a:t>ssjjul3.github.io/chartrunner</a:t>
             </a:r>
           </a:p>
         </p:txBody>
@@ -6063,7 +6063,7 @@
                 </a:solidFill>
                 <a:latin typeface="Consolas"/>
               </a:rPr>
-              <a:t>github.com/chartrunner-xyz/chartrunner</a:t>
+              <a:t>github.com/ssjjul3/chartrunner</a:t>
             </a:r>
           </a:p>
         </p:txBody>
@@ -6092,13 +6092,13 @@
           <a:p>
             <a:pPr algn="ctr"/>
             <a:r>
-              <a:rPr sz="1300" b="1" i="0">
+              <a:rPr sz="1200" b="1" i="0">
                 <a:solidFill>
                   <a:srgbClr val="FFFFFF"/>
                 </a:solidFill>
-                <a:latin typeface="Calibri"/>
-              </a:rPr>
-              <a:t>@chartrunner_xyz</a:t>
+                <a:latin typeface="Consolas"/>
+              </a:rPr>
+              <a:t>ssjjul3.github.io/chartrunner</a:t>
             </a:r>
           </a:p>
         </p:txBody>
@@ -6127,13 +6127,13 @@
           <a:p>
             <a:pPr algn="r"/>
             <a:r>
-              <a:rPr sz="1300" b="1" i="0">
+              <a:rPr sz="1200" b="1" i="0">
                 <a:solidFill>
                   <a:srgbClr val="FFFFFF"/>
                 </a:solidFill>
                 <a:latin typeface="Calibri"/>
               </a:rPr>
-              <a:t>chartrunner.xyz</a:t>
+              <a:t>jsg@julianroy.com</a:t>
             </a:r>
           </a:p>
         </p:txBody>
@@ -6168,7 +6168,7 @@
                 </a:solidFill>
                 <a:latin typeface="Calibri"/>
               </a:rPr>
-              <a:t>Repo · X · live demo</a:t>
+              <a:t>Repo  ·  Live demo  ·  Email</a:t>
             </a:r>
           </a:p>
         </p:txBody>

</xml_diff>